<commit_message>
docs(pricing): 턴당 원가 분해를 실측값으로 정정 (55:45 → 51.6:48.4)
덱의 동반자/분석기 분해가 추정치였다. 실측(84 샘플)은 동반자 $0.00356 /
분석기 $0.00334로, 합계 $0.00690(9.6원)은 그대로지만 비중이 거의 반반이다.

- 05 모델 배치: 동반자 합 $0.0038→$0.0036, 분석기 합 $0.0031→$0.0033
- 07 가격안 A(900턴): 4,750/3,890 → 4,458/4,182 (합 8,640원 유지)
- 07 가격안 B(1,500턴): 7,920/6,480 → 7,430/6,970 (합 14,400원 유지)

합계·수지 결론은 바뀌지 않는다. 다만 "분석기는 부차적 비용"이라는 인상이
틀렸다는 점이 중요하다 — 원가 절감 레버의 절반은 분석기 쪽에 있다.
</commit_message>
<xml_diff>
--- a/docs/마음이음_AI모델_가격정책_2026-10-01.pptx
+++ b/docs/마음이음_AI모델_가격정책_2026-10-01.pptx
@@ -7270,7 +7270,7 @@
                           </a:solidFill>
                           <a:latin typeface="Pretendard"/>
                         </a:rPr>
-                        <a:t>3.8-flash  ·  동반자 합 $0.0038</a:t>
+                        <a:t>3.8-flash  ·  동반자 합 $0.0036</a:t>
                       </a:r>
                     </a:p>
                   </a:txBody>
@@ -7446,7 +7446,7 @@
                           </a:solidFill>
                           <a:latin typeface="Pretendard"/>
                         </a:rPr>
-                        <a:t>3.8-flash  ·  분석기 합 $0.0031</a:t>
+                        <a:t>3.8-flash  ·  분석기 합 $0.0033</a:t>
                       </a:r>
                     </a:p>
                   </a:txBody>
@@ -11993,7 +11993,7 @@
         <p:spPr>
           <a:xfrm>
             <a:off x="5394960" y="5321808"/>
-            <a:ext cx="1520190" cy="566928"/>
+            <a:ext cx="1426738" cy="566928"/>
           </a:xfrm>
           <a:prstGeom prst="roundRect">
             <a:avLst>
@@ -12036,7 +12036,7 @@
                 </a:solidFill>
                 <a:latin typeface="Pretendard SemiBold"/>
               </a:rPr>
-              <a:t>4,750</a:t>
+              <a:t>4,458</a:t>
             </a:r>
           </a:p>
         </p:txBody>
@@ -12049,8 +12049,8 @@
         </p:nvSpPr>
         <p:spPr>
           <a:xfrm>
-            <a:off x="6915150" y="5321808"/>
-            <a:ext cx="1244955" cy="566928"/>
+            <a:off x="6821698" y="5321808"/>
+            <a:ext cx="1338407" cy="566928"/>
           </a:xfrm>
           <a:prstGeom prst="roundRect">
             <a:avLst>
@@ -12093,7 +12093,7 @@
                 </a:solidFill>
                 <a:latin typeface="Pretendard SemiBold"/>
               </a:rPr>
-              <a:t>3,890</a:t>
+              <a:t>4,182</a:t>
             </a:r>
           </a:p>
         </p:txBody>
@@ -12479,7 +12479,7 @@
         <p:spPr>
           <a:xfrm>
             <a:off x="5394960" y="7653527"/>
-            <a:ext cx="2534716" cy="566928"/>
+            <a:ext cx="2377897" cy="566928"/>
           </a:xfrm>
           <a:prstGeom prst="roundRect">
             <a:avLst>
@@ -12522,7 +12522,7 @@
                 </a:solidFill>
                 <a:latin typeface="Pretendard SemiBold"/>
               </a:rPr>
-              <a:t>7,920</a:t>
+              <a:t>7,430</a:t>
             </a:r>
           </a:p>
         </p:txBody>
@@ -12535,8 +12535,8 @@
         </p:nvSpPr>
         <p:spPr>
           <a:xfrm>
-            <a:off x="7929676" y="7653527"/>
-            <a:ext cx="2073859" cy="566928"/>
+            <a:off x="7772857" y="7653527"/>
+            <a:ext cx="2230678" cy="566928"/>
           </a:xfrm>
           <a:prstGeom prst="roundRect">
             <a:avLst>
@@ -12579,7 +12579,7 @@
                 </a:solidFill>
                 <a:latin typeface="Pretendard SemiBold"/>
               </a:rPr>
-              <a:t>6,480</a:t>
+              <a:t>6,970</a:t>
             </a:r>
           </a:p>
         </p:txBody>

</xml_diff>